<commit_message>
Rework admin guide videos: no voice-over, visual highlights, fix artifacts
- Replace the narrated videos with voice-less walkthroughs: highlight rings
  on click targets, spotlight dimming for key moments, on-screen captions and
  a generated music bed. Drop the .vtt caption files and the caption track.
- Fix flicker (overlay was hidden while taking screenshots during recording),
  badge/caption overlap, misaligned intro step list and a cramped outro.
- Use 25 fps throughout; video and deck screenshots come from separate runs.
- Rename guide step "narration" to "caption"; update guide page, overview,
  changelog and presentation accordingly.
- Use "Markdown-Hilfe schließen" (standard German spelling).

Refs #64
</commit_message>
<xml_diff>
--- a/docs/presentations/admin-anleitung.pptx
+++ b/docs/presentations/admin-anleitung.pptx
@@ -594,7 +594,7 @@
           <a:lstStyle/>
           <a:p>
             <a:r>
-              <a:t>Zum Schluss klickst du auf Speichern. Die neue Episode erscheint sofort in der Liste und auf der öffentlichen Podcast-Seite.</a:t>
+              <a:t>Klicke auf Speichern. Die Episode erscheint sofort auf der Webseite.</a:t>
             </a:r>
           </a:p>
         </p:txBody>
@@ -664,7 +664,7 @@
           <a:lstStyle/>
           <a:p>
             <a:r>
-              <a:t>Melde dich im Admin an. Unter Angebote findest du die Liste. Klicke beim gewünschten Angebot auf Bearbeiten.</a:t>
+              <a:t>Melde dich im Admin an. Hier sind alle Angebote. Klicke auf Bearbeiten.</a:t>
             </a:r>
           </a:p>
         </p:txBody>
@@ -734,7 +734,7 @@
           <a:lstStyle/>
           <a:p>
             <a:r>
-              <a:t>Wichtig: Nur Titel und Kategorie sind Pflicht. Alle anderen Felder sind optional. Was du leer lässt, wird auf der Webseite einfach nicht angezeigt.</a:t>
+              <a:t>Nur Titel und Kategorie sind Pflicht. Alles andere ist optional. Leere Felder erscheinen nicht auf der Webseite.</a:t>
             </a:r>
           </a:p>
         </p:txBody>
@@ -804,7 +804,7 @@
           <a:lstStyle/>
           <a:p>
             <a:r>
-              <a:t>Ändere nun, was sich geändert hat, zum Beispiel die Zeiten und den Ort. Die Webadresse des Angebots bleibt dabei gleich.</a:t>
+              <a:t>Ändere Zeiten und Ort. Die Webadresse bleibt gleich.</a:t>
             </a:r>
           </a:p>
         </p:txBody>
@@ -874,7 +874,7 @@
           <a:lstStyle/>
           <a:p>
             <a:r>
-              <a:t>Eine Ansprechperson ergänzt du mit einem Klick. Name, Rolle und Kontakt sind alle optional, nur der Name ist nötig, damit die Zeile gespeichert wird.</a:t>
+              <a:t>Füge eine Ansprechperson hinzu. Nur der Name ist nötig.</a:t>
             </a:r>
           </a:p>
         </p:txBody>
@@ -944,7 +944,7 @@
           <a:lstStyle/>
           <a:p>
             <a:r>
-              <a:t>Willst du das Kartenbild ersetzen, wähle ein neues Bild und schneide es zu. Wählst du keins, bleibt das bisherige Bild bestehen.</a:t>
+              <a:t>Wähle ein neues Kartenbild und schneide es zu. Ohne neues Bild bleibt das alte.</a:t>
             </a:r>
           </a:p>
         </p:txBody>
@@ -1014,7 +1014,7 @@
           <a:lstStyle/>
           <a:p>
             <a:r>
-              <a:t>Die Beschreibung formatierst du mit der Markdown-Hilfe. Ein Klick auf Überschrift oder Aufzählung genügt. Fett geht auch mit Strg und B.</a:t>
+              <a:t>Öffne die Markdown-Hilfe. Ein Klick auf Überschrift oder Aufzählung genügt. Fett geht auch mit Strg und B.</a:t>
             </a:r>
           </a:p>
         </p:txBody>
@@ -1084,7 +1084,7 @@
           <a:lstStyle/>
           <a:p>
             <a:r>
-              <a:t>Zum Schluss auf Speichern klicken. Auf der Webseite siehst du das Ergebnis, und leere Felder tauchen dort gar nicht erst auf.</a:t>
+              <a:t>Klicke auf Speichern. Leere Felder fehlen auf der Webseite.</a:t>
             </a:r>
           </a:p>
         </p:txBody>
@@ -1434,7 +1434,7 @@
           <a:lstStyle/>
           <a:p>
             <a:r>
-              <a:t>Öffne die Admin-Seite und melde dich mit dem Passwort an. Dann wechselst du oben auf Podcast.</a:t>
+              <a:t>Melde dich im Admin an. Wechsle zu Podcast.</a:t>
             </a:r>
           </a:p>
         </p:txBody>
@@ -1504,7 +1504,7 @@
           <a:lstStyle/>
           <a:p>
             <a:r>
-              <a:t>Hier siehst du alle bisherigen Episoden. Mit einem Klick auf Neue Episode öffnet sich das Formular.</a:t>
+              <a:t>Hier siehst du alle Episoden. Klicke auf Neue Episode.</a:t>
             </a:r>
           </a:p>
         </p:txBody>
@@ -1574,7 +1574,7 @@
           <a:lstStyle/>
           <a:p>
             <a:r>
-              <a:t>Pflichtfelder sind mit einem Stern markiert. Trage den Titel und das Veröffentlichungsdatum ein. Die Episodennummer wird automatisch vorgeschlagen.</a:t>
+              <a:t>Pflichtfelder haben einen Stern. Trage Titel und Datum ein. Die Nummer wird automatisch vorgeschlagen.</a:t>
             </a:r>
           </a:p>
         </p:txBody>
@@ -1644,7 +1644,7 @@
           <a:lstStyle/>
           <a:p>
             <a:r>
-              <a:t>Wähle jetzt die Audiodatei aus. Die Dauer wird automatisch aus der Datei übernommen, du musst sie nicht abtippen.</a:t>
+              <a:t>Wähle die Audiodatei aus. Die Dauer wird automatisch erkannt.</a:t>
             </a:r>
           </a:p>
         </p:txBody>
@@ -1714,7 +1714,7 @@
           <a:lstStyle/>
           <a:p>
             <a:r>
-              <a:t>Optional kannst du Sprecher hinzufügen. Setze den Haken bei Hauptsprecher, wenn die Person die Predigt hält. Auch das darfst du leer lassen.</a:t>
+              <a:t>Sprecher sind optional. Markiere den Hauptsprecher. Oder lass das Feld einfach leer.</a:t>
             </a:r>
           </a:p>
         </p:txBody>
@@ -1784,7 +1784,7 @@
           <a:lstStyle/>
           <a:p>
             <a:r>
-              <a:t>Ein Cover-Bild ist optional. Nach der Auswahl schneidest du es zu: Bild verschieben, zoomen, und Zuschnitt übernehmen.</a:t>
+              <a:t>Auch das Cover ist optional. Schneide das Bild zu und übernimm es.</a:t>
             </a:r>
           </a:p>
         </p:txBody>
@@ -1854,7 +1854,7 @@
           <a:lstStyle/>
           <a:p>
             <a:r>
-              <a:t>Für die Shownotes öffnest du die Markdown-Hilfe. Ein Klick fügt Formatierungen ein. Markierten Text machst du mit Strg und B fett, und mit Strg und I kursiv.</a:t>
+              <a:t>Öffne die Markdown-Hilfe. Ein Klick fügt Formatierungen ein. Mit Strg und B wird Text fett, mit Strg und I kursiv.</a:t>
             </a:r>
           </a:p>
         </p:txBody>
@@ -8935,7 +8935,7 @@
                 </a:solidFill>
                 <a:latin typeface="Open Sans"/>
               </a:rPr>
-              <a:t>Unter «Anleitungen» im Admin: Video mit Ton oben, Schritte zum Nachlesen darunter.</a:t>
+              <a:t>Unter «Anleitungen» im Admin: Video oben, Schritte zum Nachlesen darunter.</a:t>
             </a:r>
           </a:p>
         </p:txBody>
@@ -10302,7 +10302,7 @@
                 </a:solidFill>
                 <a:latin typeface="Open Sans"/>
               </a:rPr>
-              <a:t>Admin, dann «Anleitungen»: Video mit Ton und Untertiteln oben, Schritte darunter.</a:t>
+              <a:t>Admin, dann «Anleitungen»: Video oben, Schritte darunter.</a:t>
             </a:r>
           </a:p>
         </p:txBody>

</xml_diff>